<commit_message>
Feat: Cap nhat slide Bai 1 cho 9 lop voi hinh anh SGK va AI minh hoa day du
</commit_message>
<xml_diff>
--- a/KHBD_Tin_học/Lớp_1/Bài_01/Slide_Tin_hoc_Lop_1_Bai01_CHIẾC_MÁY_TÍNH_CỦA_EM.pptx
+++ b/KHBD_Tin_học/Lớp_1/Bài_01/Slide_Tin_hoc_Lop_1_Bai01_CHIẾC_MÁY_TÍNH_CỦA_EM.pptx
@@ -3105,16 +3105,85 @@
         <p:nvPr/>
       </p:nvGrpSpPr>
       <p:grpSpPr/>
-      <p:sp>
-        <p:nvSpPr>
-          <p:cNvPr id="2" name="Rounded Rectangle 1"/>
+      <p:pic>
+        <p:nvPicPr>
+          <p:cNvPr id="2" name="Picture 1" descr="cover.png"/>
+          <p:cNvPicPr>
+            <a:picLocks noChangeAspect="1"/>
+          </p:cNvPicPr>
+          <p:nvPr/>
+        </p:nvPicPr>
+        <p:blipFill>
+          <a:blip r:embed="rId2"/>
+          <a:stretch>
+            <a:fillRect/>
+          </a:stretch>
+        </p:blipFill>
+        <p:spPr>
+          <a:xfrm>
+            <a:off x="7117080" y="1188720"/>
+            <a:ext cx="4572000" cy="4572000"/>
+          </a:xfrm>
+          <a:prstGeom prst="rect">
+            <a:avLst/>
+          </a:prstGeom>
+        </p:spPr>
+      </p:pic>
+      <p:sp>
+        <p:nvSpPr>
+          <p:cNvPr id="3" name="Rounded Rectangle 2"/>
           <p:cNvSpPr/>
           <p:nvPr/>
         </p:nvSpPr>
         <p:spPr>
           <a:xfrm>
-            <a:off x="1524000" y="1280160"/>
-            <a:ext cx="9144000" cy="4206240"/>
+            <a:off x="6797040" y="1097280"/>
+            <a:ext cx="5212080" cy="4754880"/>
+          </a:xfrm>
+          <a:prstGeom prst="roundRect">
+            <a:avLst>
+              <a:gd name="adj" fmla="val 3000"/>
+            </a:avLst>
+          </a:prstGeom>
+          <a:noFill/>
+          <a:ln w="38100">
+            <a:solidFill>
+              <a:srgbClr val="FFEB3B"/>
+            </a:solidFill>
+          </a:ln>
+        </p:spPr>
+        <p:style>
+          <a:lnRef idx="1">
+            <a:schemeClr val="accent1"/>
+          </a:lnRef>
+          <a:fillRef idx="3">
+            <a:schemeClr val="accent1"/>
+          </a:fillRef>
+          <a:effectRef idx="2">
+            <a:schemeClr val="accent1"/>
+          </a:effectRef>
+          <a:fontRef idx="minor">
+            <a:schemeClr val="lt1"/>
+          </a:fontRef>
+        </p:style>
+        <p:txBody>
+          <a:bodyPr rtlCol="0" anchor="ctr"/>
+          <a:lstStyle/>
+          <a:p>
+            <a:pPr algn="ctr"/>
+          </a:p>
+        </p:txBody>
+      </p:sp>
+      <p:sp>
+        <p:nvSpPr>
+          <p:cNvPr id="4" name="Rounded Rectangle 3"/>
+          <p:cNvSpPr/>
+          <p:nvPr/>
+        </p:nvSpPr>
+        <p:spPr>
+          <a:xfrm>
+            <a:off x="365760" y="1280160"/>
+            <a:ext cx="6858000" cy="4206240"/>
           </a:xfrm>
           <a:prstGeom prst="roundRect">
             <a:avLst>
@@ -3152,13 +3221,13 @@
       </p:sp>
       <p:sp>
         <p:nvSpPr>
-          <p:cNvPr id="3" name="Rounded Rectangle 2"/>
+          <p:cNvPr id="5" name="Rounded Rectangle 4"/>
           <p:cNvSpPr/>
           <p:nvPr/>
         </p:nvSpPr>
         <p:spPr>
           <a:xfrm>
-            <a:off x="1981200" y="1554480"/>
+            <a:off x="822960" y="1554480"/>
             <a:ext cx="4114800" cy="457200"/>
           </a:xfrm>
           <a:prstGeom prst="roundRect">
@@ -3206,14 +3275,14 @@
       </p:sp>
       <p:sp>
         <p:nvSpPr>
-          <p:cNvPr id="4" name="TextBox 3"/>
+          <p:cNvPr id="6" name="TextBox 5"/>
           <p:cNvSpPr txBox="1"/>
           <p:nvPr/>
         </p:nvSpPr>
         <p:spPr>
           <a:xfrm>
-            <a:off x="1981200" y="2286000"/>
-            <a:ext cx="8229600" cy="2011680"/>
+            <a:off x="822960" y="2286000"/>
+            <a:ext cx="5943600" cy="2011680"/>
           </a:xfrm>
           <a:prstGeom prst="rect">
             <a:avLst/>
@@ -3272,14 +3341,14 @@
       </p:sp>
       <p:sp>
         <p:nvSpPr>
-          <p:cNvPr id="5" name="TextBox 4"/>
+          <p:cNvPr id="7" name="TextBox 6"/>
           <p:cNvSpPr txBox="1"/>
           <p:nvPr/>
         </p:nvSpPr>
         <p:spPr>
           <a:xfrm>
-            <a:off x="1981200" y="4389120"/>
-            <a:ext cx="8229600" cy="914400"/>
+            <a:off x="822960" y="4389120"/>
+            <a:ext cx="5943600" cy="914400"/>
           </a:xfrm>
           <a:prstGeom prst="rect">
             <a:avLst/>
@@ -3317,7 +3386,7 @@
       </p:sp>
       <p:sp>
         <p:nvSpPr>
-          <p:cNvPr id="6" name="Rectangle 5"/>
+          <p:cNvPr id="8" name="Rectangle 7"/>
           <p:cNvSpPr/>
           <p:nvPr/>
         </p:nvSpPr>
@@ -3360,7 +3429,7 @@
       </p:sp>
       <p:sp>
         <p:nvSpPr>
-          <p:cNvPr id="7" name="TextBox 6"/>
+          <p:cNvPr id="9" name="TextBox 8"/>
           <p:cNvSpPr txBox="1"/>
           <p:nvPr/>
         </p:nvSpPr>
@@ -3419,9 +3488,78 @@
         <p:nvPr/>
       </p:nvGrpSpPr>
       <p:grpSpPr/>
-      <p:sp>
-        <p:nvSpPr>
-          <p:cNvPr id="2" name="Rounded Rectangle 1"/>
+      <p:pic>
+        <p:nvPicPr>
+          <p:cNvPr id="2" name="Picture 1" descr="cover.png"/>
+          <p:cNvPicPr>
+            <a:picLocks noChangeAspect="1"/>
+          </p:cNvPicPr>
+          <p:nvPr/>
+        </p:nvPicPr>
+        <p:blipFill>
+          <a:blip r:embed="rId2"/>
+          <a:stretch>
+            <a:fillRect/>
+          </a:stretch>
+        </p:blipFill>
+        <p:spPr>
+          <a:xfrm>
+            <a:off x="7391400" y="1371600"/>
+            <a:ext cx="4114800" cy="4114800"/>
+          </a:xfrm>
+          <a:prstGeom prst="rect">
+            <a:avLst/>
+          </a:prstGeom>
+        </p:spPr>
+      </p:pic>
+      <p:sp>
+        <p:nvSpPr>
+          <p:cNvPr id="3" name="Rectangle 2"/>
+          <p:cNvSpPr/>
+          <p:nvPr/>
+        </p:nvSpPr>
+        <p:spPr>
+          <a:xfrm>
+            <a:off x="7162800" y="1371600"/>
+            <a:ext cx="4572000" cy="4114800"/>
+          </a:xfrm>
+          <a:prstGeom prst="rect">
+            <a:avLst/>
+          </a:prstGeom>
+          <a:solidFill>
+            <a:srgbClr val="4ECA54">
+              <a:alpha val="50000"/>
+            </a:srgbClr>
+          </a:solidFill>
+          <a:ln>
+            <a:noFill/>
+          </a:ln>
+        </p:spPr>
+        <p:style>
+          <a:lnRef idx="1">
+            <a:schemeClr val="accent1"/>
+          </a:lnRef>
+          <a:fillRef idx="3">
+            <a:schemeClr val="accent1"/>
+          </a:fillRef>
+          <a:effectRef idx="2">
+            <a:schemeClr val="accent1"/>
+          </a:effectRef>
+          <a:fontRef idx="minor">
+            <a:schemeClr val="lt1"/>
+          </a:fontRef>
+        </p:style>
+        <p:txBody>
+          <a:bodyPr rtlCol="0" anchor="ctr"/>
+          <a:lstStyle/>
+          <a:p>
+            <a:pPr algn="ctr"/>
+          </a:p>
+        </p:txBody>
+      </p:sp>
+      <p:sp>
+        <p:nvSpPr>
+          <p:cNvPr id="4" name="Rounded Rectangle 3"/>
           <p:cNvSpPr/>
           <p:nvPr/>
         </p:nvSpPr>
@@ -3466,7 +3604,7 @@
       </p:sp>
       <p:sp>
         <p:nvSpPr>
-          <p:cNvPr id="3" name="TextBox 2"/>
+          <p:cNvPr id="5" name="TextBox 4"/>
           <p:cNvSpPr txBox="1"/>
           <p:nvPr/>
         </p:nvSpPr>
@@ -3517,7 +3655,7 @@
       </p:sp>
       <p:sp>
         <p:nvSpPr>
-          <p:cNvPr id="4" name="TextBox 3"/>
+          <p:cNvPr id="6" name="TextBox 5"/>
           <p:cNvSpPr txBox="1"/>
           <p:nvPr/>
         </p:nvSpPr>
@@ -3552,7 +3690,7 @@
       </p:sp>
       <p:sp>
         <p:nvSpPr>
-          <p:cNvPr id="5" name="Rectangle 4"/>
+          <p:cNvPr id="7" name="Rectangle 6"/>
           <p:cNvSpPr/>
           <p:nvPr/>
         </p:nvSpPr>
@@ -3595,7 +3733,7 @@
       </p:sp>
       <p:sp>
         <p:nvSpPr>
-          <p:cNvPr id="6" name="TextBox 5"/>
+          <p:cNvPr id="8" name="TextBox 7"/>
           <p:cNvSpPr txBox="1"/>
           <p:nvPr/>
         </p:nvSpPr>
@@ -3662,8 +3800,8 @@
         </p:nvSpPr>
         <p:spPr>
           <a:xfrm>
-            <a:off x="838200" y="1188720"/>
-            <a:ext cx="10515600" cy="4389120"/>
+            <a:off x="320040" y="1188720"/>
+            <a:ext cx="7132320" cy="4389120"/>
           </a:xfrm>
           <a:prstGeom prst="roundRect">
             <a:avLst>
@@ -3714,7 +3852,7 @@
         </p:nvSpPr>
         <p:spPr>
           <a:xfrm>
-            <a:off x="838200" y="1188720"/>
+            <a:off x="320040" y="1188720"/>
             <a:ext cx="109728" cy="4389120"/>
           </a:xfrm>
           <a:prstGeom prst="rect">
@@ -3757,8 +3895,8 @@
         </p:nvSpPr>
         <p:spPr>
           <a:xfrm>
-            <a:off x="1295400" y="1371600"/>
-            <a:ext cx="9144000" cy="457200"/>
+            <a:off x="777240" y="1371600"/>
+            <a:ext cx="6400800" cy="457200"/>
           </a:xfrm>
           <a:prstGeom prst="rect">
             <a:avLst/>
@@ -3793,8 +3931,8 @@
         </p:nvSpPr>
         <p:spPr>
           <a:xfrm>
-            <a:off x="1295400" y="2011680"/>
-            <a:ext cx="9601200" cy="3291840"/>
+            <a:off x="777240" y="2011680"/>
+            <a:ext cx="6400800" cy="3291840"/>
           </a:xfrm>
           <a:prstGeom prst="rect">
             <a:avLst/>
@@ -3920,9 +4058,33 @@
           </a:p>
         </p:txBody>
       </p:sp>
-      <p:sp>
-        <p:nvSpPr>
-          <p:cNvPr id="6" name="Rectangle 5"/>
+      <p:pic>
+        <p:nvPicPr>
+          <p:cNvPr id="6" name="Picture 5" descr="cover.png"/>
+          <p:cNvPicPr>
+            <a:picLocks noChangeAspect="1"/>
+          </p:cNvPicPr>
+          <p:nvPr/>
+        </p:nvPicPr>
+        <p:blipFill>
+          <a:blip r:embed="rId2"/>
+          <a:stretch>
+            <a:fillRect/>
+          </a:stretch>
+        </p:blipFill>
+        <p:spPr>
+          <a:xfrm>
+            <a:off x="7680960" y="1287780"/>
+            <a:ext cx="4191000" cy="4191000"/>
+          </a:xfrm>
+          <a:prstGeom prst="rect">
+            <a:avLst/>
+          </a:prstGeom>
+        </p:spPr>
+      </p:pic>
+      <p:sp>
+        <p:nvSpPr>
+          <p:cNvPr id="7" name="Rectangle 6"/>
           <p:cNvSpPr/>
           <p:nvPr/>
         </p:nvSpPr>
@@ -3965,7 +4127,7 @@
       </p:sp>
       <p:sp>
         <p:nvSpPr>
-          <p:cNvPr id="7" name="TextBox 6"/>
+          <p:cNvPr id="8" name="TextBox 7"/>
           <p:cNvSpPr txBox="1"/>
           <p:nvPr/>
         </p:nvSpPr>
@@ -4032,8 +4194,8 @@
         </p:nvSpPr>
         <p:spPr>
           <a:xfrm>
-            <a:off x="457200" y="1188720"/>
-            <a:ext cx="6858000" cy="4389120"/>
+            <a:off x="320040" y="1188720"/>
+            <a:ext cx="6400800" cy="4389120"/>
           </a:xfrm>
           <a:prstGeom prst="roundRect">
             <a:avLst>
@@ -4084,7 +4246,7 @@
         </p:nvSpPr>
         <p:spPr>
           <a:xfrm>
-            <a:off x="457200" y="1188720"/>
+            <a:off x="320040" y="1188720"/>
             <a:ext cx="109728" cy="4389120"/>
           </a:xfrm>
           <a:prstGeom prst="rect">
@@ -4127,8 +4289,8 @@
         </p:nvSpPr>
         <p:spPr>
           <a:xfrm>
-            <a:off x="822960" y="1371600"/>
-            <a:ext cx="6126480" cy="457200"/>
+            <a:off x="685800" y="1371600"/>
+            <a:ext cx="5669280" cy="457200"/>
           </a:xfrm>
           <a:prstGeom prst="rect">
             <a:avLst/>
@@ -4163,8 +4325,8 @@
         </p:nvSpPr>
         <p:spPr>
           <a:xfrm>
-            <a:off x="822960" y="2011680"/>
-            <a:ext cx="6126480" cy="3291840"/>
+            <a:off x="685800" y="2011680"/>
+            <a:ext cx="5669280" cy="3291840"/>
           </a:xfrm>
           <a:prstGeom prst="rect">
             <a:avLst/>
@@ -4242,21 +4404,21 @@
         </p:nvSpPr>
         <p:spPr>
           <a:xfrm>
-            <a:off x="7437120" y="1188720"/>
-            <a:ext cx="4389120" cy="4389120"/>
+            <a:off x="6949440" y="1188720"/>
+            <a:ext cx="4922520" cy="4389120"/>
           </a:xfrm>
           <a:prstGeom prst="roundRect">
             <a:avLst>
-              <a:gd name="adj" fmla="val 4000"/>
+              <a:gd name="adj" fmla="val 3000"/>
             </a:avLst>
           </a:prstGeom>
           <a:solidFill>
-            <a:srgbClr val="4ECA54">
-              <a:alpha val="20000"/>
-            </a:srgbClr>
+            <a:srgbClr val="F8F8F8"/>
           </a:solidFill>
-          <a:ln>
-            <a:noFill/>
+          <a:ln w="19050">
+            <a:solidFill>
+              <a:srgbClr val="4ECA54"/>
+            </a:solidFill>
           </a:ln>
         </p:spPr>
         <p:style>
@@ -4281,45 +4443,87 @@
           </a:p>
         </p:txBody>
       </p:sp>
-      <p:sp>
-        <p:nvSpPr>
-          <p:cNvPr id="7" name="TextBox 6"/>
-          <p:cNvSpPr txBox="1"/>
-          <p:nvPr/>
-        </p:nvSpPr>
-        <p:spPr>
-          <a:xfrm>
-            <a:off x="9174480" y="2926080"/>
-            <a:ext cx="914400" cy="914400"/>
+      <p:pic>
+        <p:nvPicPr>
+          <p:cNvPr id="7" name="Picture 6" descr="activity.png"/>
+          <p:cNvPicPr>
+            <a:picLocks noChangeAspect="1"/>
+          </p:cNvPicPr>
+          <p:nvPr/>
+        </p:nvPicPr>
+        <p:blipFill>
+          <a:blip r:embed="rId2"/>
+          <a:stretch>
+            <a:fillRect/>
+          </a:stretch>
+        </p:blipFill>
+        <p:spPr>
+          <a:xfrm>
+            <a:off x="7353300" y="1325880"/>
+            <a:ext cx="4114800" cy="4114800"/>
           </a:xfrm>
           <a:prstGeom prst="rect">
             <a:avLst/>
           </a:prstGeom>
-          <a:noFill/>
-        </p:spPr>
-        <p:txBody>
-          <a:bodyPr wrap="square">
-            <a:spAutoFit/>
-          </a:bodyPr>
-          <a:lstStyle/>
-          <a:p>
-            <a:pPr algn="ctr">
-              <a:defRPr sz="4800" b="0">
+        </p:spPr>
+      </p:pic>
+      <p:sp>
+        <p:nvSpPr>
+          <p:cNvPr id="8" name="Rounded Rectangle 7"/>
+          <p:cNvSpPr/>
+          <p:nvPr/>
+        </p:nvSpPr>
+        <p:spPr>
+          <a:xfrm>
+            <a:off x="10683240" y="1280160"/>
+            <a:ext cx="1097280" cy="274320"/>
+          </a:xfrm>
+          <a:prstGeom prst="roundRect">
+            <a:avLst>
+              <a:gd name="adj" fmla="val 30000"/>
+            </a:avLst>
+          </a:prstGeom>
+          <a:solidFill>
+            <a:srgbClr val="4ECA54"/>
+          </a:solidFill>
+          <a:ln>
+            <a:noFill/>
+          </a:ln>
+        </p:spPr>
+        <p:style>
+          <a:lnRef idx="1">
+            <a:schemeClr val="accent1"/>
+          </a:lnRef>
+          <a:fillRef idx="3">
+            <a:schemeClr val="accent1"/>
+          </a:fillRef>
+          <a:effectRef idx="2">
+            <a:schemeClr val="accent1"/>
+          </a:effectRef>
+          <a:fontRef idx="minor">
+            <a:schemeClr val="lt1"/>
+          </a:fontRef>
+        </p:style>
+        <p:txBody>
+          <a:bodyPr rtlCol="0" anchor="ctr"/>
+          <a:lstStyle/>
+          <a:p>
+            <a:pPr algn="ctr"/>
+            <a:r>
+              <a:rPr sz="1000" b="1">
                 <a:solidFill>
                   <a:srgbClr val="FFFFFF"/>
                 </a:solidFill>
                 <a:latin typeface="Times New Roman"/>
-              </a:defRPr>
-            </a:pPr>
-            <a:r>
-              <a:t>🎮</a:t>
-            </a:r>
-          </a:p>
-        </p:txBody>
-      </p:sp>
-      <p:sp>
-        <p:nvSpPr>
-          <p:cNvPr id="8" name="Rectangle 7"/>
+              </a:rPr>
+              <a:t>📚 SGK</a:t>
+            </a:r>
+          </a:p>
+        </p:txBody>
+      </p:sp>
+      <p:sp>
+        <p:nvSpPr>
+          <p:cNvPr id="9" name="Rectangle 8"/>
           <p:cNvSpPr/>
           <p:nvPr/>
         </p:nvSpPr>
@@ -4362,7 +4566,7 @@
       </p:sp>
       <p:sp>
         <p:nvSpPr>
-          <p:cNvPr id="9" name="TextBox 8"/>
+          <p:cNvPr id="10" name="TextBox 9"/>
           <p:cNvSpPr txBox="1"/>
           <p:nvPr/>
         </p:nvSpPr>
@@ -4429,8 +4633,8 @@
         </p:nvSpPr>
         <p:spPr>
           <a:xfrm>
-            <a:off x="4876800" y="1188720"/>
-            <a:ext cx="6858000" cy="4389120"/>
+            <a:off x="5577840" y="1188720"/>
+            <a:ext cx="6400800" cy="4389120"/>
           </a:xfrm>
           <a:prstGeom prst="roundRect">
             <a:avLst>
@@ -4481,7 +4685,7 @@
         </p:nvSpPr>
         <p:spPr>
           <a:xfrm>
-            <a:off x="11625072" y="1188720"/>
+            <a:off x="11868912" y="1188720"/>
             <a:ext cx="109728" cy="4389120"/>
           </a:xfrm>
           <a:prstGeom prst="rect">
@@ -4524,8 +4728,8 @@
         </p:nvSpPr>
         <p:spPr>
           <a:xfrm>
-            <a:off x="5242560" y="1371600"/>
-            <a:ext cx="6126480" cy="457200"/>
+            <a:off x="5943600" y="1371600"/>
+            <a:ext cx="5669280" cy="457200"/>
           </a:xfrm>
           <a:prstGeom prst="rect">
             <a:avLst/>
@@ -4560,8 +4764,8 @@
         </p:nvSpPr>
         <p:spPr>
           <a:xfrm>
-            <a:off x="5242560" y="2011680"/>
-            <a:ext cx="6126480" cy="3291840"/>
+            <a:off x="5943600" y="2011680"/>
+            <a:ext cx="5669280" cy="3291840"/>
           </a:xfrm>
           <a:prstGeom prst="rect">
             <a:avLst/>
@@ -4667,21 +4871,21 @@
         </p:nvSpPr>
         <p:spPr>
           <a:xfrm>
-            <a:off x="457200" y="1188720"/>
-            <a:ext cx="4389120" cy="4389120"/>
+            <a:off x="320040" y="1188720"/>
+            <a:ext cx="5029200" cy="4389120"/>
           </a:xfrm>
           <a:prstGeom prst="roundRect">
             <a:avLst>
-              <a:gd name="adj" fmla="val 4000"/>
+              <a:gd name="adj" fmla="val 3000"/>
             </a:avLst>
           </a:prstGeom>
           <a:solidFill>
-            <a:srgbClr val="4ECA54">
-              <a:alpha val="20000"/>
-            </a:srgbClr>
+            <a:srgbClr val="F8F8F8"/>
           </a:solidFill>
-          <a:ln>
-            <a:noFill/>
+          <a:ln w="19050">
+            <a:solidFill>
+              <a:srgbClr val="4ECA54"/>
+            </a:solidFill>
           </a:ln>
         </p:spPr>
         <p:style>
@@ -4706,45 +4910,87 @@
           </a:p>
         </p:txBody>
       </p:sp>
-      <p:sp>
-        <p:nvSpPr>
-          <p:cNvPr id="7" name="TextBox 6"/>
-          <p:cNvSpPr txBox="1"/>
-          <p:nvPr/>
-        </p:nvSpPr>
-        <p:spPr>
-          <a:xfrm>
-            <a:off x="2194560" y="2926080"/>
-            <a:ext cx="914400" cy="914400"/>
+      <p:pic>
+        <p:nvPicPr>
+          <p:cNvPr id="7" name="Picture 6" descr="activity.png"/>
+          <p:cNvPicPr>
+            <a:picLocks noChangeAspect="1"/>
+          </p:cNvPicPr>
+          <p:nvPr/>
+        </p:nvPicPr>
+        <p:blipFill>
+          <a:blip r:embed="rId2"/>
+          <a:stretch>
+            <a:fillRect/>
+          </a:stretch>
+        </p:blipFill>
+        <p:spPr>
+          <a:xfrm>
+            <a:off x="777240" y="1325880"/>
+            <a:ext cx="4114800" cy="4114800"/>
           </a:xfrm>
           <a:prstGeom prst="rect">
             <a:avLst/>
           </a:prstGeom>
-          <a:noFill/>
-        </p:spPr>
-        <p:txBody>
-          <a:bodyPr wrap="square">
-            <a:spAutoFit/>
-          </a:bodyPr>
-          <a:lstStyle/>
-          <a:p>
-            <a:pPr algn="ctr">
-              <a:defRPr sz="4800" b="0">
+        </p:spPr>
+      </p:pic>
+      <p:sp>
+        <p:nvSpPr>
+          <p:cNvPr id="8" name="Rounded Rectangle 7"/>
+          <p:cNvSpPr/>
+          <p:nvPr/>
+        </p:nvSpPr>
+        <p:spPr>
+          <a:xfrm>
+            <a:off x="4160520" y="1280160"/>
+            <a:ext cx="1097280" cy="274320"/>
+          </a:xfrm>
+          <a:prstGeom prst="roundRect">
+            <a:avLst>
+              <a:gd name="adj" fmla="val 30000"/>
+            </a:avLst>
+          </a:prstGeom>
+          <a:solidFill>
+            <a:srgbClr val="4ECA54"/>
+          </a:solidFill>
+          <a:ln>
+            <a:noFill/>
+          </a:ln>
+        </p:spPr>
+        <p:style>
+          <a:lnRef idx="1">
+            <a:schemeClr val="accent1"/>
+          </a:lnRef>
+          <a:fillRef idx="3">
+            <a:schemeClr val="accent1"/>
+          </a:fillRef>
+          <a:effectRef idx="2">
+            <a:schemeClr val="accent1"/>
+          </a:effectRef>
+          <a:fontRef idx="minor">
+            <a:schemeClr val="lt1"/>
+          </a:fontRef>
+        </p:style>
+        <p:txBody>
+          <a:bodyPr rtlCol="0" anchor="ctr"/>
+          <a:lstStyle/>
+          <a:p>
+            <a:pPr algn="ctr"/>
+            <a:r>
+              <a:rPr sz="1000" b="1">
                 <a:solidFill>
                   <a:srgbClr val="FFFFFF"/>
                 </a:solidFill>
                 <a:latin typeface="Times New Roman"/>
-              </a:defRPr>
-            </a:pPr>
-            <a:r>
-              <a:t>📖</a:t>
-            </a:r>
-          </a:p>
-        </p:txBody>
-      </p:sp>
-      <p:sp>
-        <p:nvSpPr>
-          <p:cNvPr id="8" name="Rectangle 7"/>
+              </a:rPr>
+              <a:t>📚 SGK</a:t>
+            </a:r>
+          </a:p>
+        </p:txBody>
+      </p:sp>
+      <p:sp>
+        <p:nvSpPr>
+          <p:cNvPr id="9" name="Rectangle 8"/>
           <p:cNvSpPr/>
           <p:nvPr/>
         </p:nvSpPr>
@@ -4787,7 +5033,7 @@
       </p:sp>
       <p:sp>
         <p:nvSpPr>
-          <p:cNvPr id="9" name="TextBox 8"/>
+          <p:cNvPr id="10" name="TextBox 9"/>
           <p:cNvSpPr txBox="1"/>
           <p:nvPr/>
         </p:nvSpPr>
@@ -4854,8 +5100,8 @@
         </p:nvSpPr>
         <p:spPr>
           <a:xfrm>
-            <a:off x="457200" y="1188720"/>
-            <a:ext cx="6858000" cy="4389120"/>
+            <a:off x="320040" y="1188720"/>
+            <a:ext cx="6400800" cy="4389120"/>
           </a:xfrm>
           <a:prstGeom prst="roundRect">
             <a:avLst>
@@ -4906,7 +5152,7 @@
         </p:nvSpPr>
         <p:spPr>
           <a:xfrm>
-            <a:off x="457200" y="1188720"/>
+            <a:off x="320040" y="1188720"/>
             <a:ext cx="109728" cy="4389120"/>
           </a:xfrm>
           <a:prstGeom prst="rect">
@@ -4949,8 +5195,8 @@
         </p:nvSpPr>
         <p:spPr>
           <a:xfrm>
-            <a:off x="822960" y="1371600"/>
-            <a:ext cx="6126480" cy="457200"/>
+            <a:off x="685800" y="1371600"/>
+            <a:ext cx="5669280" cy="457200"/>
           </a:xfrm>
           <a:prstGeom prst="rect">
             <a:avLst/>
@@ -4985,8 +5231,8 @@
         </p:nvSpPr>
         <p:spPr>
           <a:xfrm>
-            <a:off x="822960" y="2011680"/>
-            <a:ext cx="6126480" cy="3291840"/>
+            <a:off x="685800" y="2011680"/>
+            <a:ext cx="5669280" cy="3291840"/>
           </a:xfrm>
           <a:prstGeom prst="rect">
             <a:avLst/>
@@ -5064,21 +5310,21 @@
         </p:nvSpPr>
         <p:spPr>
           <a:xfrm>
-            <a:off x="7437120" y="1188720"/>
-            <a:ext cx="4389120" cy="4389120"/>
+            <a:off x="6949440" y="1188720"/>
+            <a:ext cx="4922520" cy="4389120"/>
           </a:xfrm>
           <a:prstGeom prst="roundRect">
             <a:avLst>
-              <a:gd name="adj" fmla="val 4000"/>
+              <a:gd name="adj" fmla="val 3000"/>
             </a:avLst>
           </a:prstGeom>
           <a:solidFill>
-            <a:srgbClr val="4ECA54">
-              <a:alpha val="20000"/>
-            </a:srgbClr>
+            <a:srgbClr val="F8F8F8"/>
           </a:solidFill>
-          <a:ln>
-            <a:noFill/>
+          <a:ln w="19050">
+            <a:solidFill>
+              <a:srgbClr val="4ECA54"/>
+            </a:solidFill>
           </a:ln>
         </p:spPr>
         <p:style>
@@ -5103,45 +5349,87 @@
           </a:p>
         </p:txBody>
       </p:sp>
-      <p:sp>
-        <p:nvSpPr>
-          <p:cNvPr id="7" name="TextBox 6"/>
-          <p:cNvSpPr txBox="1"/>
-          <p:nvPr/>
-        </p:nvSpPr>
-        <p:spPr>
-          <a:xfrm>
-            <a:off x="9174480" y="2926080"/>
-            <a:ext cx="914400" cy="914400"/>
+      <p:pic>
+        <p:nvPicPr>
+          <p:cNvPr id="7" name="Picture 6" descr="activity.png"/>
+          <p:cNvPicPr>
+            <a:picLocks noChangeAspect="1"/>
+          </p:cNvPicPr>
+          <p:nvPr/>
+        </p:nvPicPr>
+        <p:blipFill>
+          <a:blip r:embed="rId2"/>
+          <a:stretch>
+            <a:fillRect/>
+          </a:stretch>
+        </p:blipFill>
+        <p:spPr>
+          <a:xfrm>
+            <a:off x="7353300" y="1325880"/>
+            <a:ext cx="4114800" cy="4114800"/>
           </a:xfrm>
           <a:prstGeom prst="rect">
             <a:avLst/>
           </a:prstGeom>
-          <a:noFill/>
-        </p:spPr>
-        <p:txBody>
-          <a:bodyPr wrap="square">
-            <a:spAutoFit/>
-          </a:bodyPr>
-          <a:lstStyle/>
-          <a:p>
-            <a:pPr algn="ctr">
-              <a:defRPr sz="4800" b="0">
+        </p:spPr>
+      </p:pic>
+      <p:sp>
+        <p:nvSpPr>
+          <p:cNvPr id="8" name="Rounded Rectangle 7"/>
+          <p:cNvSpPr/>
+          <p:nvPr/>
+        </p:nvSpPr>
+        <p:spPr>
+          <a:xfrm>
+            <a:off x="10683240" y="1280160"/>
+            <a:ext cx="1097280" cy="274320"/>
+          </a:xfrm>
+          <a:prstGeom prst="roundRect">
+            <a:avLst>
+              <a:gd name="adj" fmla="val 30000"/>
+            </a:avLst>
+          </a:prstGeom>
+          <a:solidFill>
+            <a:srgbClr val="4ECA54"/>
+          </a:solidFill>
+          <a:ln>
+            <a:noFill/>
+          </a:ln>
+        </p:spPr>
+        <p:style>
+          <a:lnRef idx="1">
+            <a:schemeClr val="accent1"/>
+          </a:lnRef>
+          <a:fillRef idx="3">
+            <a:schemeClr val="accent1"/>
+          </a:fillRef>
+          <a:effectRef idx="2">
+            <a:schemeClr val="accent1"/>
+          </a:effectRef>
+          <a:fontRef idx="minor">
+            <a:schemeClr val="lt1"/>
+          </a:fontRef>
+        </p:style>
+        <p:txBody>
+          <a:bodyPr rtlCol="0" anchor="ctr"/>
+          <a:lstStyle/>
+          <a:p>
+            <a:pPr algn="ctr"/>
+            <a:r>
+              <a:rPr sz="1000" b="1">
                 <a:solidFill>
                   <a:srgbClr val="FFFFFF"/>
                 </a:solidFill>
                 <a:latin typeface="Times New Roman"/>
-              </a:defRPr>
-            </a:pPr>
-            <a:r>
-              <a:t>📖</a:t>
-            </a:r>
-          </a:p>
-        </p:txBody>
-      </p:sp>
-      <p:sp>
-        <p:nvSpPr>
-          <p:cNvPr id="8" name="Rectangle 7"/>
+              </a:rPr>
+              <a:t>📚 SGK</a:t>
+            </a:r>
+          </a:p>
+        </p:txBody>
+      </p:sp>
+      <p:sp>
+        <p:nvSpPr>
+          <p:cNvPr id="9" name="Rectangle 8"/>
           <p:cNvSpPr/>
           <p:nvPr/>
         </p:nvSpPr>
@@ -5184,7 +5472,7 @@
       </p:sp>
       <p:sp>
         <p:nvSpPr>
-          <p:cNvPr id="9" name="TextBox 8"/>
+          <p:cNvPr id="10" name="TextBox 9"/>
           <p:cNvSpPr txBox="1"/>
           <p:nvPr/>
         </p:nvSpPr>
@@ -5251,8 +5539,8 @@
         </p:nvSpPr>
         <p:spPr>
           <a:xfrm>
-            <a:off x="4876800" y="1188720"/>
-            <a:ext cx="6858000" cy="4389120"/>
+            <a:off x="5577840" y="1188720"/>
+            <a:ext cx="6400800" cy="4389120"/>
           </a:xfrm>
           <a:prstGeom prst="roundRect">
             <a:avLst>
@@ -5303,7 +5591,7 @@
         </p:nvSpPr>
         <p:spPr>
           <a:xfrm>
-            <a:off x="11625072" y="1188720"/>
+            <a:off x="11868912" y="1188720"/>
             <a:ext cx="109728" cy="4389120"/>
           </a:xfrm>
           <a:prstGeom prst="rect">
@@ -5346,8 +5634,8 @@
         </p:nvSpPr>
         <p:spPr>
           <a:xfrm>
-            <a:off x="5242560" y="1371600"/>
-            <a:ext cx="6126480" cy="457200"/>
+            <a:off x="5943600" y="1371600"/>
+            <a:ext cx="5669280" cy="457200"/>
           </a:xfrm>
           <a:prstGeom prst="rect">
             <a:avLst/>
@@ -5382,8 +5670,8 @@
         </p:nvSpPr>
         <p:spPr>
           <a:xfrm>
-            <a:off x="5242560" y="2011680"/>
-            <a:ext cx="6126480" cy="3291840"/>
+            <a:off x="5943600" y="2011680"/>
+            <a:ext cx="5669280" cy="3291840"/>
           </a:xfrm>
           <a:prstGeom prst="rect">
             <a:avLst/>
@@ -5461,21 +5749,21 @@
         </p:nvSpPr>
         <p:spPr>
           <a:xfrm>
-            <a:off x="457200" y="1188720"/>
-            <a:ext cx="4389120" cy="4389120"/>
+            <a:off x="320040" y="1188720"/>
+            <a:ext cx="5029200" cy="4389120"/>
           </a:xfrm>
           <a:prstGeom prst="roundRect">
             <a:avLst>
-              <a:gd name="adj" fmla="val 4000"/>
+              <a:gd name="adj" fmla="val 3000"/>
             </a:avLst>
           </a:prstGeom>
           <a:solidFill>
-            <a:srgbClr val="4ECA54">
-              <a:alpha val="20000"/>
-            </a:srgbClr>
+            <a:srgbClr val="F8F8F8"/>
           </a:solidFill>
-          <a:ln>
-            <a:noFill/>
+          <a:ln w="19050">
+            <a:solidFill>
+              <a:srgbClr val="4ECA54"/>
+            </a:solidFill>
           </a:ln>
         </p:spPr>
         <p:style>
@@ -5500,45 +5788,87 @@
           </a:p>
         </p:txBody>
       </p:sp>
-      <p:sp>
-        <p:nvSpPr>
-          <p:cNvPr id="7" name="TextBox 6"/>
-          <p:cNvSpPr txBox="1"/>
-          <p:nvPr/>
-        </p:nvSpPr>
-        <p:spPr>
-          <a:xfrm>
-            <a:off x="2194560" y="2926080"/>
-            <a:ext cx="914400" cy="914400"/>
+      <p:pic>
+        <p:nvPicPr>
+          <p:cNvPr id="7" name="Picture 6" descr="practice.png"/>
+          <p:cNvPicPr>
+            <a:picLocks noChangeAspect="1"/>
+          </p:cNvPicPr>
+          <p:nvPr/>
+        </p:nvPicPr>
+        <p:blipFill>
+          <a:blip r:embed="rId2"/>
+          <a:stretch>
+            <a:fillRect/>
+          </a:stretch>
+        </p:blipFill>
+        <p:spPr>
+          <a:xfrm>
+            <a:off x="777240" y="1325880"/>
+            <a:ext cx="4114800" cy="4114800"/>
           </a:xfrm>
           <a:prstGeom prst="rect">
             <a:avLst/>
           </a:prstGeom>
-          <a:noFill/>
-        </p:spPr>
-        <p:txBody>
-          <a:bodyPr wrap="square">
-            <a:spAutoFit/>
-          </a:bodyPr>
-          <a:lstStyle/>
-          <a:p>
-            <a:pPr algn="ctr">
-              <a:defRPr sz="4800" b="0">
+        </p:spPr>
+      </p:pic>
+      <p:sp>
+        <p:nvSpPr>
+          <p:cNvPr id="8" name="Rounded Rectangle 7"/>
+          <p:cNvSpPr/>
+          <p:nvPr/>
+        </p:nvSpPr>
+        <p:spPr>
+          <a:xfrm>
+            <a:off x="4160520" y="1280160"/>
+            <a:ext cx="1097280" cy="274320"/>
+          </a:xfrm>
+          <a:prstGeom prst="roundRect">
+            <a:avLst>
+              <a:gd name="adj" fmla="val 30000"/>
+            </a:avLst>
+          </a:prstGeom>
+          <a:solidFill>
+            <a:srgbClr val="4ECA54"/>
+          </a:solidFill>
+          <a:ln>
+            <a:noFill/>
+          </a:ln>
+        </p:spPr>
+        <p:style>
+          <a:lnRef idx="1">
+            <a:schemeClr val="accent1"/>
+          </a:lnRef>
+          <a:fillRef idx="3">
+            <a:schemeClr val="accent1"/>
+          </a:fillRef>
+          <a:effectRef idx="2">
+            <a:schemeClr val="accent1"/>
+          </a:effectRef>
+          <a:fontRef idx="minor">
+            <a:schemeClr val="lt1"/>
+          </a:fontRef>
+        </p:style>
+        <p:txBody>
+          <a:bodyPr rtlCol="0" anchor="ctr"/>
+          <a:lstStyle/>
+          <a:p>
+            <a:pPr algn="ctr"/>
+            <a:r>
+              <a:rPr sz="1000" b="1">
                 <a:solidFill>
                   <a:srgbClr val="FFFFFF"/>
                 </a:solidFill>
                 <a:latin typeface="Times New Roman"/>
-              </a:defRPr>
-            </a:pPr>
-            <a:r>
-              <a:t>✏️</a:t>
-            </a:r>
-          </a:p>
-        </p:txBody>
-      </p:sp>
-      <p:sp>
-        <p:nvSpPr>
-          <p:cNvPr id="8" name="Rectangle 7"/>
+              </a:rPr>
+              <a:t>📚 SGK</a:t>
+            </a:r>
+          </a:p>
+        </p:txBody>
+      </p:sp>
+      <p:sp>
+        <p:nvSpPr>
+          <p:cNvPr id="9" name="Rectangle 8"/>
           <p:cNvSpPr/>
           <p:nvPr/>
         </p:nvSpPr>
@@ -5581,7 +5911,7 @@
       </p:sp>
       <p:sp>
         <p:nvSpPr>
-          <p:cNvPr id="9" name="TextBox 8"/>
+          <p:cNvPr id="10" name="TextBox 9"/>
           <p:cNvSpPr txBox="1"/>
           <p:nvPr/>
         </p:nvSpPr>
@@ -5648,8 +5978,8 @@
         </p:nvSpPr>
         <p:spPr>
           <a:xfrm>
-            <a:off x="457200" y="1188720"/>
-            <a:ext cx="6858000" cy="4389120"/>
+            <a:off x="320040" y="1188720"/>
+            <a:ext cx="6400800" cy="4389120"/>
           </a:xfrm>
           <a:prstGeom prst="roundRect">
             <a:avLst>
@@ -5700,7 +6030,7 @@
         </p:nvSpPr>
         <p:spPr>
           <a:xfrm>
-            <a:off x="457200" y="1188720"/>
+            <a:off x="320040" y="1188720"/>
             <a:ext cx="109728" cy="4389120"/>
           </a:xfrm>
           <a:prstGeom prst="rect">
@@ -5743,8 +6073,8 @@
         </p:nvSpPr>
         <p:spPr>
           <a:xfrm>
-            <a:off x="822960" y="1371600"/>
-            <a:ext cx="6126480" cy="457200"/>
+            <a:off x="685800" y="1371600"/>
+            <a:ext cx="5669280" cy="457200"/>
           </a:xfrm>
           <a:prstGeom prst="rect">
             <a:avLst/>
@@ -5779,8 +6109,8 @@
         </p:nvSpPr>
         <p:spPr>
           <a:xfrm>
-            <a:off x="822960" y="2011680"/>
-            <a:ext cx="6126480" cy="3291840"/>
+            <a:off x="685800" y="2011680"/>
+            <a:ext cx="5669280" cy="3291840"/>
           </a:xfrm>
           <a:prstGeom prst="rect">
             <a:avLst/>
@@ -5858,21 +6188,21 @@
         </p:nvSpPr>
         <p:spPr>
           <a:xfrm>
-            <a:off x="7437120" y="1188720"/>
-            <a:ext cx="4389120" cy="4389120"/>
+            <a:off x="6949440" y="1188720"/>
+            <a:ext cx="4922520" cy="4389120"/>
           </a:xfrm>
           <a:prstGeom prst="roundRect">
             <a:avLst>
-              <a:gd name="adj" fmla="val 4000"/>
+              <a:gd name="adj" fmla="val 3000"/>
             </a:avLst>
           </a:prstGeom>
           <a:solidFill>
-            <a:srgbClr val="4ECA54">
-              <a:alpha val="20000"/>
-            </a:srgbClr>
+            <a:srgbClr val="F8F8F8"/>
           </a:solidFill>
-          <a:ln>
-            <a:noFill/>
+          <a:ln w="19050">
+            <a:solidFill>
+              <a:srgbClr val="4ECA54"/>
+            </a:solidFill>
           </a:ln>
         </p:spPr>
         <p:style>
@@ -5897,45 +6227,87 @@
           </a:p>
         </p:txBody>
       </p:sp>
-      <p:sp>
-        <p:nvSpPr>
-          <p:cNvPr id="7" name="TextBox 6"/>
-          <p:cNvSpPr txBox="1"/>
-          <p:nvPr/>
-        </p:nvSpPr>
-        <p:spPr>
-          <a:xfrm>
-            <a:off x="9174480" y="2926080"/>
-            <a:ext cx="914400" cy="914400"/>
+      <p:pic>
+        <p:nvPicPr>
+          <p:cNvPr id="7" name="Picture 6" descr="practice.png"/>
+          <p:cNvPicPr>
+            <a:picLocks noChangeAspect="1"/>
+          </p:cNvPicPr>
+          <p:nvPr/>
+        </p:nvPicPr>
+        <p:blipFill>
+          <a:blip r:embed="rId2"/>
+          <a:stretch>
+            <a:fillRect/>
+          </a:stretch>
+        </p:blipFill>
+        <p:spPr>
+          <a:xfrm>
+            <a:off x="7353300" y="1325880"/>
+            <a:ext cx="4114800" cy="4114800"/>
           </a:xfrm>
           <a:prstGeom prst="rect">
             <a:avLst/>
           </a:prstGeom>
-          <a:noFill/>
-        </p:spPr>
-        <p:txBody>
-          <a:bodyPr wrap="square">
-            <a:spAutoFit/>
-          </a:bodyPr>
-          <a:lstStyle/>
-          <a:p>
-            <a:pPr algn="ctr">
-              <a:defRPr sz="4800" b="0">
+        </p:spPr>
+      </p:pic>
+      <p:sp>
+        <p:nvSpPr>
+          <p:cNvPr id="8" name="Rounded Rectangle 7"/>
+          <p:cNvSpPr/>
+          <p:nvPr/>
+        </p:nvSpPr>
+        <p:spPr>
+          <a:xfrm>
+            <a:off x="10683240" y="1280160"/>
+            <a:ext cx="1097280" cy="274320"/>
+          </a:xfrm>
+          <a:prstGeom prst="roundRect">
+            <a:avLst>
+              <a:gd name="adj" fmla="val 30000"/>
+            </a:avLst>
+          </a:prstGeom>
+          <a:solidFill>
+            <a:srgbClr val="4ECA54"/>
+          </a:solidFill>
+          <a:ln>
+            <a:noFill/>
+          </a:ln>
+        </p:spPr>
+        <p:style>
+          <a:lnRef idx="1">
+            <a:schemeClr val="accent1"/>
+          </a:lnRef>
+          <a:fillRef idx="3">
+            <a:schemeClr val="accent1"/>
+          </a:fillRef>
+          <a:effectRef idx="2">
+            <a:schemeClr val="accent1"/>
+          </a:effectRef>
+          <a:fontRef idx="minor">
+            <a:schemeClr val="lt1"/>
+          </a:fontRef>
+        </p:style>
+        <p:txBody>
+          <a:bodyPr rtlCol="0" anchor="ctr"/>
+          <a:lstStyle/>
+          <a:p>
+            <a:pPr algn="ctr"/>
+            <a:r>
+              <a:rPr sz="1000" b="1">
                 <a:solidFill>
                   <a:srgbClr val="FFFFFF"/>
                 </a:solidFill>
                 <a:latin typeface="Times New Roman"/>
-              </a:defRPr>
-            </a:pPr>
-            <a:r>
-              <a:t>✏️</a:t>
-            </a:r>
-          </a:p>
-        </p:txBody>
-      </p:sp>
-      <p:sp>
-        <p:nvSpPr>
-          <p:cNvPr id="8" name="Rectangle 7"/>
+              </a:rPr>
+              <a:t>📚 SGK</a:t>
+            </a:r>
+          </a:p>
+        </p:txBody>
+      </p:sp>
+      <p:sp>
+        <p:nvSpPr>
+          <p:cNvPr id="9" name="Rectangle 8"/>
           <p:cNvSpPr/>
           <p:nvPr/>
         </p:nvSpPr>
@@ -5978,7 +6350,7 @@
       </p:sp>
       <p:sp>
         <p:nvSpPr>
-          <p:cNvPr id="9" name="TextBox 8"/>
+          <p:cNvPr id="10" name="TextBox 9"/>
           <p:cNvSpPr txBox="1"/>
           <p:nvPr/>
         </p:nvSpPr>
@@ -6045,8 +6417,8 @@
         </p:nvSpPr>
         <p:spPr>
           <a:xfrm>
-            <a:off x="457200" y="1188720"/>
-            <a:ext cx="6858000" cy="4389120"/>
+            <a:off x="320040" y="1188720"/>
+            <a:ext cx="6400800" cy="4389120"/>
           </a:xfrm>
           <a:prstGeom prst="roundRect">
             <a:avLst>
@@ -6097,7 +6469,7 @@
         </p:nvSpPr>
         <p:spPr>
           <a:xfrm>
-            <a:off x="457200" y="1188720"/>
+            <a:off x="320040" y="1188720"/>
             <a:ext cx="109728" cy="4389120"/>
           </a:xfrm>
           <a:prstGeom prst="rect">
@@ -6140,8 +6512,8 @@
         </p:nvSpPr>
         <p:spPr>
           <a:xfrm>
-            <a:off x="822960" y="1371600"/>
-            <a:ext cx="6126480" cy="457200"/>
+            <a:off x="685800" y="1371600"/>
+            <a:ext cx="5669280" cy="457200"/>
           </a:xfrm>
           <a:prstGeom prst="rect">
             <a:avLst/>
@@ -6176,8 +6548,8 @@
         </p:nvSpPr>
         <p:spPr>
           <a:xfrm>
-            <a:off x="822960" y="2011680"/>
-            <a:ext cx="6126480" cy="3291840"/>
+            <a:off x="685800" y="2011680"/>
+            <a:ext cx="5669280" cy="3291840"/>
           </a:xfrm>
           <a:prstGeom prst="rect">
             <a:avLst/>
@@ -6283,21 +6655,21 @@
         </p:nvSpPr>
         <p:spPr>
           <a:xfrm>
-            <a:off x="7437120" y="1188720"/>
-            <a:ext cx="4389120" cy="4389120"/>
+            <a:off x="6949440" y="1188720"/>
+            <a:ext cx="4922520" cy="4389120"/>
           </a:xfrm>
           <a:prstGeom prst="roundRect">
             <a:avLst>
-              <a:gd name="adj" fmla="val 4000"/>
+              <a:gd name="adj" fmla="val 3000"/>
             </a:avLst>
           </a:prstGeom>
           <a:solidFill>
-            <a:srgbClr val="4ECA54">
-              <a:alpha val="20000"/>
-            </a:srgbClr>
+            <a:srgbClr val="F8F8F8"/>
           </a:solidFill>
-          <a:ln>
-            <a:noFill/>
+          <a:ln w="19050">
+            <a:solidFill>
+              <a:srgbClr val="4ECA54"/>
+            </a:solidFill>
           </a:ln>
         </p:spPr>
         <p:style>
@@ -6322,45 +6694,87 @@
           </a:p>
         </p:txBody>
       </p:sp>
-      <p:sp>
-        <p:nvSpPr>
-          <p:cNvPr id="7" name="TextBox 6"/>
-          <p:cNvSpPr txBox="1"/>
-          <p:nvPr/>
-        </p:nvSpPr>
-        <p:spPr>
-          <a:xfrm>
-            <a:off x="9174480" y="2926080"/>
-            <a:ext cx="914400" cy="914400"/>
+      <p:pic>
+        <p:nvPicPr>
+          <p:cNvPr id="7" name="Picture 6" descr="practice.png"/>
+          <p:cNvPicPr>
+            <a:picLocks noChangeAspect="1"/>
+          </p:cNvPicPr>
+          <p:nvPr/>
+        </p:nvPicPr>
+        <p:blipFill>
+          <a:blip r:embed="rId2"/>
+          <a:stretch>
+            <a:fillRect/>
+          </a:stretch>
+        </p:blipFill>
+        <p:spPr>
+          <a:xfrm>
+            <a:off x="7353300" y="1325880"/>
+            <a:ext cx="4114800" cy="4114800"/>
           </a:xfrm>
           <a:prstGeom prst="rect">
             <a:avLst/>
           </a:prstGeom>
-          <a:noFill/>
-        </p:spPr>
-        <p:txBody>
-          <a:bodyPr wrap="square">
-            <a:spAutoFit/>
-          </a:bodyPr>
-          <a:lstStyle/>
-          <a:p>
-            <a:pPr algn="ctr">
-              <a:defRPr sz="4800" b="0">
+        </p:spPr>
+      </p:pic>
+      <p:sp>
+        <p:nvSpPr>
+          <p:cNvPr id="8" name="Rounded Rectangle 7"/>
+          <p:cNvSpPr/>
+          <p:nvPr/>
+        </p:nvSpPr>
+        <p:spPr>
+          <a:xfrm>
+            <a:off x="10683240" y="1280160"/>
+            <a:ext cx="1097280" cy="274320"/>
+          </a:xfrm>
+          <a:prstGeom prst="roundRect">
+            <a:avLst>
+              <a:gd name="adj" fmla="val 30000"/>
+            </a:avLst>
+          </a:prstGeom>
+          <a:solidFill>
+            <a:srgbClr val="4ECA54"/>
+          </a:solidFill>
+          <a:ln>
+            <a:noFill/>
+          </a:ln>
+        </p:spPr>
+        <p:style>
+          <a:lnRef idx="1">
+            <a:schemeClr val="accent1"/>
+          </a:lnRef>
+          <a:fillRef idx="3">
+            <a:schemeClr val="accent1"/>
+          </a:fillRef>
+          <a:effectRef idx="2">
+            <a:schemeClr val="accent1"/>
+          </a:effectRef>
+          <a:fontRef idx="minor">
+            <a:schemeClr val="lt1"/>
+          </a:fontRef>
+        </p:style>
+        <p:txBody>
+          <a:bodyPr rtlCol="0" anchor="ctr"/>
+          <a:lstStyle/>
+          <a:p>
+            <a:pPr algn="ctr"/>
+            <a:r>
+              <a:rPr sz="1000" b="1">
                 <a:solidFill>
                   <a:srgbClr val="FFFFFF"/>
                 </a:solidFill>
                 <a:latin typeface="Times New Roman"/>
-              </a:defRPr>
-            </a:pPr>
-            <a:r>
-              <a:t>🚀</a:t>
-            </a:r>
-          </a:p>
-        </p:txBody>
-      </p:sp>
-      <p:sp>
-        <p:nvSpPr>
-          <p:cNvPr id="8" name="Rectangle 7"/>
+              </a:rPr>
+              <a:t>📚 SGK</a:t>
+            </a:r>
+          </a:p>
+        </p:txBody>
+      </p:sp>
+      <p:sp>
+        <p:nvSpPr>
+          <p:cNvPr id="9" name="Rectangle 8"/>
           <p:cNvSpPr/>
           <p:nvPr/>
         </p:nvSpPr>
@@ -6403,7 +6817,7 @@
       </p:sp>
       <p:sp>
         <p:nvSpPr>
-          <p:cNvPr id="9" name="TextBox 8"/>
+          <p:cNvPr id="10" name="TextBox 9"/>
           <p:cNvSpPr txBox="1"/>
           <p:nvPr/>
         </p:nvSpPr>
@@ -6470,8 +6884,8 @@
         </p:nvSpPr>
         <p:spPr>
           <a:xfrm>
-            <a:off x="472440" y="1188720"/>
-            <a:ext cx="11247120" cy="4389120"/>
+            <a:off x="320040" y="1188720"/>
+            <a:ext cx="7315200" cy="4389120"/>
           </a:xfrm>
           <a:prstGeom prst="roundRect">
             <a:avLst>
@@ -6522,7 +6936,7 @@
         </p:nvSpPr>
         <p:spPr>
           <a:xfrm>
-            <a:off x="472440" y="1188720"/>
+            <a:off x="320040" y="1188720"/>
             <a:ext cx="109728" cy="4389120"/>
           </a:xfrm>
           <a:prstGeom prst="rect">
@@ -6565,8 +6979,8 @@
         </p:nvSpPr>
         <p:spPr>
           <a:xfrm>
-            <a:off x="929640" y="1371600"/>
-            <a:ext cx="10058400" cy="457200"/>
+            <a:off x="777240" y="1371600"/>
+            <a:ext cx="6400800" cy="457200"/>
           </a:xfrm>
           <a:prstGeom prst="rect">
             <a:avLst/>
@@ -6601,8 +7015,8 @@
         </p:nvSpPr>
         <p:spPr>
           <a:xfrm>
-            <a:off x="929640" y="2011680"/>
-            <a:ext cx="10058400" cy="3291840"/>
+            <a:off x="777240" y="2011680"/>
+            <a:ext cx="6400800" cy="3291840"/>
           </a:xfrm>
           <a:prstGeom prst="rect">
             <a:avLst/>
@@ -6728,9 +7142,33 @@
           </a:p>
         </p:txBody>
       </p:sp>
-      <p:sp>
-        <p:nvSpPr>
-          <p:cNvPr id="6" name="Rectangle 5"/>
+      <p:pic>
+        <p:nvPicPr>
+          <p:cNvPr id="6" name="Picture 5" descr="summary.png"/>
+          <p:cNvPicPr>
+            <a:picLocks noChangeAspect="1"/>
+          </p:cNvPicPr>
+          <p:nvPr/>
+        </p:nvPicPr>
+        <p:blipFill>
+          <a:blip r:embed="rId2"/>
+          <a:stretch>
+            <a:fillRect/>
+          </a:stretch>
+        </p:blipFill>
+        <p:spPr>
+          <a:xfrm>
+            <a:off x="7863840" y="1379220"/>
+            <a:ext cx="4008120" cy="4008120"/>
+          </a:xfrm>
+          <a:prstGeom prst="rect">
+            <a:avLst/>
+          </a:prstGeom>
+        </p:spPr>
+      </p:pic>
+      <p:sp>
+        <p:nvSpPr>
+          <p:cNvPr id="7" name="Rectangle 6"/>
           <p:cNvSpPr/>
           <p:nvPr/>
         </p:nvSpPr>
@@ -6773,7 +7211,7 @@
       </p:sp>
       <p:sp>
         <p:nvSpPr>
-          <p:cNvPr id="7" name="TextBox 6"/>
+          <p:cNvPr id="8" name="TextBox 7"/>
           <p:cNvSpPr txBox="1"/>
           <p:nvPr/>
         </p:nvSpPr>

</xml_diff>